<commit_message>
Update Refinement on DeviceIdentifier-API-FullReference.docx
</commit_message>
<xml_diff>
--- a/Reference/DeviceIdentifierBriefing.pptx
+++ b/Reference/DeviceIdentifierBriefing.pptx
@@ -5,7 +5,7 @@
     <p:sldMasterId id="2147483648" r:id="rId1"/>
   </p:sldMasterIdLst>
   <p:notesMasterIdLst>
-    <p:notesMasterId r:id="rId12"/>
+    <p:notesMasterId r:id="rId13"/>
   </p:notesMasterIdLst>
   <p:sldIdLst>
     <p:sldId id="256" r:id="rId2"/>
@@ -14,10 +14,11 @@
     <p:sldId id="260" r:id="rId5"/>
     <p:sldId id="269" r:id="rId6"/>
     <p:sldId id="416" r:id="rId7"/>
-    <p:sldId id="276" r:id="rId8"/>
-    <p:sldId id="262" r:id="rId9"/>
-    <p:sldId id="270" r:id="rId10"/>
-    <p:sldId id="257" r:id="rId11"/>
+    <p:sldId id="417" r:id="rId8"/>
+    <p:sldId id="276" r:id="rId9"/>
+    <p:sldId id="262" r:id="rId10"/>
+    <p:sldId id="270" r:id="rId11"/>
+    <p:sldId id="257" r:id="rId12"/>
   </p:sldIdLst>
   <p:sldSz cx="12192000" cy="6858000"/>
   <p:notesSz cx="6858000" cy="9144000"/>
@@ -983,7 +984,7 @@
           <a:p>
             <a:fld id="{5BCAD085-E8A6-8845-BD4E-CB4CCA059FC4}" type="datetimeFigureOut">
               <a:rPr lang="en-US" smtClean="0"/>
-              <a:t>9/2/2026</a:t>
+              <a:t>9/18/2026</a:t>
             </a:fld>
             <a:endParaRPr lang="en-US"/>
           </a:p>
@@ -1151,7 +1152,7 @@
           <a:p>
             <a:fld id="{5BCAD085-E8A6-8845-BD4E-CB4CCA059FC4}" type="datetimeFigureOut">
               <a:rPr lang="en-US" smtClean="0"/>
-              <a:t>9/2/2026</a:t>
+              <a:t>9/18/2026</a:t>
             </a:fld>
             <a:endParaRPr lang="en-US"/>
           </a:p>
@@ -1329,7 +1330,7 @@
           <a:p>
             <a:fld id="{5BCAD085-E8A6-8845-BD4E-CB4CCA059FC4}" type="datetimeFigureOut">
               <a:rPr lang="en-US" smtClean="0"/>
-              <a:t>9/2/2026</a:t>
+              <a:t>9/18/2026</a:t>
             </a:fld>
             <a:endParaRPr lang="en-US"/>
           </a:p>
@@ -1534,7 +1535,7 @@
           <a:p>
             <a:fld id="{1CD01395-AC05-405C-BAB9-E5D2B9FDBB40}" type="datetimeFigureOut">
               <a:rPr lang="en-MY" smtClean="0"/>
-              <a:t>2/9/2026</a:t>
+              <a:t>18/9/2026</a:t>
             </a:fld>
             <a:endParaRPr lang="en-MY"/>
           </a:p>
@@ -1702,7 +1703,7 @@
           <a:p>
             <a:fld id="{5BCAD085-E8A6-8845-BD4E-CB4CCA059FC4}" type="datetimeFigureOut">
               <a:rPr lang="en-US" smtClean="0"/>
-              <a:t>9/2/2026</a:t>
+              <a:t>9/18/2026</a:t>
             </a:fld>
             <a:endParaRPr lang="en-US"/>
           </a:p>
@@ -1947,7 +1948,7 @@
           <a:p>
             <a:fld id="{5BCAD085-E8A6-8845-BD4E-CB4CCA059FC4}" type="datetimeFigureOut">
               <a:rPr lang="en-US" smtClean="0"/>
-              <a:t>9/2/2026</a:t>
+              <a:t>9/18/2026</a:t>
             </a:fld>
             <a:endParaRPr lang="en-US"/>
           </a:p>
@@ -2232,7 +2233,7 @@
           <a:p>
             <a:fld id="{5BCAD085-E8A6-8845-BD4E-CB4CCA059FC4}" type="datetimeFigureOut">
               <a:rPr lang="en-US" smtClean="0"/>
-              <a:t>9/2/2026</a:t>
+              <a:t>9/18/2026</a:t>
             </a:fld>
             <a:endParaRPr lang="en-US"/>
           </a:p>
@@ -2651,7 +2652,7 @@
           <a:p>
             <a:fld id="{5BCAD085-E8A6-8845-BD4E-CB4CCA059FC4}" type="datetimeFigureOut">
               <a:rPr lang="en-US" smtClean="0"/>
-              <a:t>9/2/2026</a:t>
+              <a:t>9/18/2026</a:t>
             </a:fld>
             <a:endParaRPr lang="en-US"/>
           </a:p>
@@ -2768,7 +2769,7 @@
           <a:p>
             <a:fld id="{5BCAD085-E8A6-8845-BD4E-CB4CCA059FC4}" type="datetimeFigureOut">
               <a:rPr lang="en-US" smtClean="0"/>
-              <a:t>9/2/2026</a:t>
+              <a:t>9/18/2026</a:t>
             </a:fld>
             <a:endParaRPr lang="en-US"/>
           </a:p>
@@ -2863,7 +2864,7 @@
           <a:p>
             <a:fld id="{5BCAD085-E8A6-8845-BD4E-CB4CCA059FC4}" type="datetimeFigureOut">
               <a:rPr lang="en-US" smtClean="0"/>
-              <a:t>9/2/2026</a:t>
+              <a:t>9/18/2026</a:t>
             </a:fld>
             <a:endParaRPr lang="en-US"/>
           </a:p>
@@ -3138,7 +3139,7 @@
           <a:p>
             <a:fld id="{5BCAD085-E8A6-8845-BD4E-CB4CCA059FC4}" type="datetimeFigureOut">
               <a:rPr lang="en-US" smtClean="0"/>
-              <a:t>9/2/2026</a:t>
+              <a:t>9/18/2026</a:t>
             </a:fld>
             <a:endParaRPr lang="en-US"/>
           </a:p>
@@ -3390,7 +3391,7 @@
           <a:p>
             <a:fld id="{5BCAD085-E8A6-8845-BD4E-CB4CCA059FC4}" type="datetimeFigureOut">
               <a:rPr lang="en-US" smtClean="0"/>
-              <a:t>9/2/2026</a:t>
+              <a:t>9/18/2026</a:t>
             </a:fld>
             <a:endParaRPr lang="en-US"/>
           </a:p>
@@ -3601,7 +3602,7 @@
           <a:p>
             <a:fld id="{5BCAD085-E8A6-8845-BD4E-CB4CCA059FC4}" type="datetimeFigureOut">
               <a:rPr lang="en-US" smtClean="0"/>
-              <a:t>9/2/2026</a:t>
+              <a:t>9/18/2026</a:t>
             </a:fld>
             <a:endParaRPr lang="en-US"/>
           </a:p>
@@ -4196,6 +4197,153 @@
 </file>
 
 <file path=ppt/slides/slide10.xml><?xml version="1.0" encoding="utf-8"?>
+<p:sld xmlns:a="http://schemas.openxmlformats.org/drawingml/2006/main" xmlns:r="http://schemas.openxmlformats.org/officeDocument/2006/relationships" xmlns:p="http://schemas.openxmlformats.org/presentationml/2006/main">
+  <p:cSld>
+    <p:spTree>
+      <p:nvGrpSpPr>
+        <p:cNvPr id="1" name="">
+          <a:extLst>
+            <a:ext uri="{FF2B5EF4-FFF2-40B4-BE49-F238E27FC236}">
+              <a16:creationId xmlns:a16="http://schemas.microsoft.com/office/drawing/2014/main" id="{4486ABC1-84AC-C1D6-3020-B6B7B4A579AA}"/>
+            </a:ext>
+          </a:extLst>
+        </p:cNvPr>
+        <p:cNvGrpSpPr/>
+        <p:nvPr/>
+      </p:nvGrpSpPr>
+      <p:grpSpPr>
+        <a:xfrm>
+          <a:off x="0" y="0"/>
+          <a:ext cx="0" cy="0"/>
+          <a:chOff x="0" y="0"/>
+          <a:chExt cx="0" cy="0"/>
+        </a:xfrm>
+      </p:grpSpPr>
+      <p:sp>
+        <p:nvSpPr>
+          <p:cNvPr id="2" name="Rectangle 1">
+            <a:extLst>
+              <a:ext uri="{FF2B5EF4-FFF2-40B4-BE49-F238E27FC236}">
+                <a16:creationId xmlns:a16="http://schemas.microsoft.com/office/drawing/2014/main" id="{DAC221A5-E89B-7CDB-57E7-88919BA17B8A}"/>
+              </a:ext>
+            </a:extLst>
+          </p:cNvPr>
+          <p:cNvSpPr/>
+          <p:nvPr/>
+        </p:nvSpPr>
+        <p:spPr>
+          <a:xfrm>
+            <a:off x="0" y="0"/>
+            <a:ext cx="12191695" cy="6858000"/>
+          </a:xfrm>
+          <a:prstGeom prst="rect">
+            <a:avLst/>
+          </a:prstGeom>
+          <a:solidFill>
+            <a:srgbClr val="1B2430"/>
+          </a:solidFill>
+          <a:ln>
+            <a:noFill/>
+          </a:ln>
+          <a:effectLst/>
+        </p:spPr>
+        <p:style>
+          <a:lnRef idx="1">
+            <a:schemeClr val="accent1"/>
+          </a:lnRef>
+          <a:fillRef idx="3">
+            <a:schemeClr val="accent1"/>
+          </a:fillRef>
+          <a:effectRef idx="2">
+            <a:schemeClr val="accent1"/>
+          </a:effectRef>
+          <a:fontRef idx="minor">
+            <a:schemeClr val="lt1"/>
+          </a:fontRef>
+        </p:style>
+        <p:txBody>
+          <a:bodyPr rtlCol="0" anchor="ctr"/>
+          <a:lstStyle/>
+          <a:p>
+            <a:pPr algn="ctr"/>
+            <a:endParaRPr/>
+          </a:p>
+        </p:txBody>
+      </p:sp>
+      <p:sp>
+        <p:nvSpPr>
+          <p:cNvPr id="3" name="TextBox 2">
+            <a:extLst>
+              <a:ext uri="{FF2B5EF4-FFF2-40B4-BE49-F238E27FC236}">
+                <a16:creationId xmlns:a16="http://schemas.microsoft.com/office/drawing/2014/main" id="{4BD1BD80-4047-F136-5392-68E72ABF82F1}"/>
+              </a:ext>
+            </a:extLst>
+          </p:cNvPr>
+          <p:cNvSpPr txBox="1"/>
+          <p:nvPr/>
+        </p:nvSpPr>
+        <p:spPr>
+          <a:xfrm>
+            <a:off x="4791075" y="3423225"/>
+            <a:ext cx="2466975" cy="584775"/>
+          </a:xfrm>
+          <a:prstGeom prst="rect">
+            <a:avLst/>
+          </a:prstGeom>
+          <a:noFill/>
+        </p:spPr>
+        <p:txBody>
+          <a:bodyPr wrap="square" lIns="0" tIns="0" rIns="0" bIns="0" anchor="t">
+            <a:spAutoFit/>
+          </a:bodyPr>
+          <a:lstStyle/>
+          <a:p>
+            <a:pPr algn="ctr">
+              <a:lnSpc>
+                <a:spcPct val="100000"/>
+              </a:lnSpc>
+            </a:pPr>
+            <a:r>
+              <a:rPr sz="3800" b="1" i="0" dirty="0">
+                <a:solidFill>
+                  <a:srgbClr val="FFFFFF"/>
+                </a:solidFill>
+                <a:latin typeface="Cambria"/>
+              </a:rPr>
+              <a:t>The </a:t>
+            </a:r>
+            <a:r>
+              <a:rPr lang="en-US" sz="3800" b="1" i="0" dirty="0">
+                <a:solidFill>
+                  <a:srgbClr val="FFFFFF"/>
+                </a:solidFill>
+                <a:latin typeface="Cambria"/>
+              </a:rPr>
+              <a:t>End</a:t>
+            </a:r>
+            <a:endParaRPr sz="3800" b="1" i="0" dirty="0">
+              <a:solidFill>
+                <a:srgbClr val="FFFFFF"/>
+              </a:solidFill>
+              <a:latin typeface="Cambria"/>
+            </a:endParaRPr>
+          </a:p>
+        </p:txBody>
+      </p:sp>
+    </p:spTree>
+    <p:extLst>
+      <p:ext uri="{BB962C8B-B14F-4D97-AF65-F5344CB8AC3E}">
+        <p14:creationId xmlns:p14="http://schemas.microsoft.com/office/powerpoint/2010/main" val="4225617154"/>
+      </p:ext>
+    </p:extLst>
+  </p:cSld>
+  <p:clrMapOvr>
+    <a:masterClrMapping/>
+  </p:clrMapOvr>
+</p:sld>
+</file>
+
+<file path=ppt/slides/slide11.xml><?xml version="1.0" encoding="utf-8"?>
 <p:sld xmlns:a="http://schemas.openxmlformats.org/drawingml/2006/main" xmlns:r="http://schemas.openxmlformats.org/officeDocument/2006/relationships" xmlns:p="http://schemas.openxmlformats.org/presentationml/2006/main" show="0">
   <p:cSld>
     <p:spTree>
@@ -8455,6 +8603,207 @@
 </file>
 
 <file path=ppt/slides/slide7.xml><?xml version="1.0" encoding="utf-8"?>
+<p:sld xmlns:a="http://schemas.openxmlformats.org/drawingml/2006/main" xmlns:r="http://schemas.openxmlformats.org/officeDocument/2006/relationships" xmlns:p="http://schemas.openxmlformats.org/presentationml/2006/main">
+  <p:cSld>
+    <p:spTree>
+      <p:nvGrpSpPr>
+        <p:cNvPr id="1" name="">
+          <a:extLst>
+            <a:ext uri="{FF2B5EF4-FFF2-40B4-BE49-F238E27FC236}">
+              <a16:creationId xmlns:a16="http://schemas.microsoft.com/office/drawing/2014/main" id="{DFDAC7D0-1A03-37CD-69EB-D146D5448E43}"/>
+            </a:ext>
+          </a:extLst>
+        </p:cNvPr>
+        <p:cNvGrpSpPr/>
+        <p:nvPr/>
+      </p:nvGrpSpPr>
+      <p:grpSpPr>
+        <a:xfrm>
+          <a:off x="0" y="0"/>
+          <a:ext cx="0" cy="0"/>
+          <a:chOff x="0" y="0"/>
+          <a:chExt cx="0" cy="0"/>
+        </a:xfrm>
+      </p:grpSpPr>
+      <p:pic>
+        <p:nvPicPr>
+          <p:cNvPr id="6" name="Picture 5">
+            <a:extLst>
+              <a:ext uri="{FF2B5EF4-FFF2-40B4-BE49-F238E27FC236}">
+                <a16:creationId xmlns:a16="http://schemas.microsoft.com/office/drawing/2014/main" id="{0770E4E3-5707-9D7B-7B36-7CB21614CC79}"/>
+              </a:ext>
+            </a:extLst>
+          </p:cNvPr>
+          <p:cNvPicPr>
+            <a:picLocks noChangeAspect="1"/>
+          </p:cNvPicPr>
+          <p:nvPr/>
+        </p:nvPicPr>
+        <p:blipFill>
+          <a:blip r:embed="rId2"/>
+          <a:stretch>
+            <a:fillRect/>
+          </a:stretch>
+        </p:blipFill>
+        <p:spPr>
+          <a:xfrm>
+            <a:off x="1464733" y="651660"/>
+            <a:ext cx="9635334" cy="5393539"/>
+          </a:xfrm>
+          <a:prstGeom prst="rect">
+            <a:avLst/>
+          </a:prstGeom>
+        </p:spPr>
+      </p:pic>
+      <p:sp>
+        <p:nvSpPr>
+          <p:cNvPr id="2" name="TextBox 1">
+            <a:extLst>
+              <a:ext uri="{FF2B5EF4-FFF2-40B4-BE49-F238E27FC236}">
+                <a16:creationId xmlns:a16="http://schemas.microsoft.com/office/drawing/2014/main" id="{A2991A1D-AA1C-BBAB-93B7-76130AF17555}"/>
+              </a:ext>
+            </a:extLst>
+          </p:cNvPr>
+          <p:cNvSpPr txBox="1"/>
+          <p:nvPr/>
+        </p:nvSpPr>
+        <p:spPr>
+          <a:xfrm>
+            <a:off x="103717" y="5883174"/>
+            <a:ext cx="3406958" cy="923330"/>
+          </a:xfrm>
+          <a:prstGeom prst="rect">
+            <a:avLst/>
+          </a:prstGeom>
+          <a:noFill/>
+        </p:spPr>
+        <p:txBody>
+          <a:bodyPr wrap="none" rtlCol="0">
+            <a:spAutoFit/>
+          </a:bodyPr>
+          <a:lstStyle/>
+          <a:p>
+            <a:r>
+              <a:rPr lang="en-US" dirty="0"/>
+              <a:t>XenAnalyticDevice.dll = logic.dll</a:t>
+            </a:r>
+          </a:p>
+          <a:p>
+            <a:r>
+              <a:rPr lang="en-US" dirty="0"/>
+              <a:t>XenAnalyticModel.dll = model.dll</a:t>
+            </a:r>
+          </a:p>
+          <a:p>
+            <a:r>
+              <a:rPr lang="en-US" dirty="0"/>
+              <a:t>XenAnalyticService.py = service.py</a:t>
+            </a:r>
+            <a:endParaRPr lang="en-MY" dirty="0"/>
+          </a:p>
+        </p:txBody>
+      </p:sp>
+      <p:sp>
+        <p:nvSpPr>
+          <p:cNvPr id="4" name="TextBox 3">
+            <a:extLst>
+              <a:ext uri="{FF2B5EF4-FFF2-40B4-BE49-F238E27FC236}">
+                <a16:creationId xmlns:a16="http://schemas.microsoft.com/office/drawing/2014/main" id="{1E426301-9CB9-1C51-270C-9B3F521AB06B}"/>
+              </a:ext>
+            </a:extLst>
+          </p:cNvPr>
+          <p:cNvSpPr txBox="1"/>
+          <p:nvPr/>
+        </p:nvSpPr>
+        <p:spPr>
+          <a:xfrm>
+            <a:off x="7962507" y="4967614"/>
+            <a:ext cx="3252301" cy="1200329"/>
+          </a:xfrm>
+          <a:prstGeom prst="rect">
+            <a:avLst/>
+          </a:prstGeom>
+          <a:noFill/>
+        </p:spPr>
+        <p:txBody>
+          <a:bodyPr wrap="none" rtlCol="0">
+            <a:spAutoFit/>
+          </a:bodyPr>
+          <a:lstStyle/>
+          <a:p>
+            <a:r>
+              <a:rPr lang="en-US" dirty="0">
+                <a:highlight>
+                  <a:srgbClr val="FFFF00"/>
+                </a:highlight>
+              </a:rPr>
+              <a:t>Inter Process Connector (IPC)</a:t>
+            </a:r>
+          </a:p>
+          <a:p>
+            <a:r>
+              <a:rPr lang="en-US" dirty="0">
+                <a:highlight>
+                  <a:srgbClr val="FFFF00"/>
+                </a:highlight>
+              </a:rPr>
+              <a:t>= communicate between </a:t>
+            </a:r>
+            <a:r>
+              <a:rPr lang="en-US" dirty="0" err="1">
+                <a:highlight>
+                  <a:srgbClr val="FFFF00"/>
+                </a:highlight>
+              </a:rPr>
+              <a:t>dll</a:t>
+            </a:r>
+            <a:r>
+              <a:rPr lang="en-US" dirty="0">
+                <a:highlight>
+                  <a:srgbClr val="FFFF00"/>
+                </a:highlight>
+              </a:rPr>
+              <a:t> and </a:t>
+            </a:r>
+          </a:p>
+          <a:p>
+            <a:endParaRPr lang="en-US" dirty="0">
+              <a:highlight>
+                <a:srgbClr val="FFFF00"/>
+              </a:highlight>
+            </a:endParaRPr>
+          </a:p>
+          <a:p>
+            <a:r>
+              <a:rPr lang="en-US" dirty="0">
+                <a:highlight>
+                  <a:srgbClr val="FFFF00"/>
+                </a:highlight>
+              </a:rPr>
+              <a:t>TCP</a:t>
+            </a:r>
+            <a:endParaRPr lang="en-MY" dirty="0">
+              <a:highlight>
+                <a:srgbClr val="FFFF00"/>
+              </a:highlight>
+            </a:endParaRPr>
+          </a:p>
+        </p:txBody>
+      </p:sp>
+    </p:spTree>
+    <p:extLst>
+      <p:ext uri="{BB962C8B-B14F-4D97-AF65-F5344CB8AC3E}">
+        <p14:creationId xmlns:p14="http://schemas.microsoft.com/office/powerpoint/2010/main" val="2770098849"/>
+      </p:ext>
+    </p:extLst>
+  </p:cSld>
+  <p:clrMapOvr>
+    <a:masterClrMapping/>
+  </p:clrMapOvr>
+</p:sld>
+</file>
+
+<file path=ppt/slides/slide8.xml><?xml version="1.0" encoding="utf-8"?>
 <p:sld xmlns:a="http://schemas.openxmlformats.org/drawingml/2006/main" xmlns:r="http://schemas.openxmlformats.org/officeDocument/2006/relationships" xmlns:p="http://schemas.openxmlformats.org/presentationml/2006/main">
   <p:cSld>
     <p:spTree>
@@ -10489,7 +10838,7 @@
 </p:sld>
 </file>
 
-<file path=ppt/slides/slide8.xml><?xml version="1.0" encoding="utf-8"?>
+<file path=ppt/slides/slide9.xml><?xml version="1.0" encoding="utf-8"?>
 <p:sld xmlns:a="http://schemas.openxmlformats.org/drawingml/2006/main" xmlns:r="http://schemas.openxmlformats.org/officeDocument/2006/relationships" xmlns:p="http://schemas.openxmlformats.org/presentationml/2006/main">
   <p:cSld>
     <p:spTree>
@@ -11064,153 +11413,6 @@
         </p:txBody>
       </p:sp>
     </p:spTree>
-  </p:cSld>
-  <p:clrMapOvr>
-    <a:masterClrMapping/>
-  </p:clrMapOvr>
-</p:sld>
-</file>
-
-<file path=ppt/slides/slide9.xml><?xml version="1.0" encoding="utf-8"?>
-<p:sld xmlns:a="http://schemas.openxmlformats.org/drawingml/2006/main" xmlns:r="http://schemas.openxmlformats.org/officeDocument/2006/relationships" xmlns:p="http://schemas.openxmlformats.org/presentationml/2006/main">
-  <p:cSld>
-    <p:spTree>
-      <p:nvGrpSpPr>
-        <p:cNvPr id="1" name="">
-          <a:extLst>
-            <a:ext uri="{FF2B5EF4-FFF2-40B4-BE49-F238E27FC236}">
-              <a16:creationId xmlns:a16="http://schemas.microsoft.com/office/drawing/2014/main" id="{4486ABC1-84AC-C1D6-3020-B6B7B4A579AA}"/>
-            </a:ext>
-          </a:extLst>
-        </p:cNvPr>
-        <p:cNvGrpSpPr/>
-        <p:nvPr/>
-      </p:nvGrpSpPr>
-      <p:grpSpPr>
-        <a:xfrm>
-          <a:off x="0" y="0"/>
-          <a:ext cx="0" cy="0"/>
-          <a:chOff x="0" y="0"/>
-          <a:chExt cx="0" cy="0"/>
-        </a:xfrm>
-      </p:grpSpPr>
-      <p:sp>
-        <p:nvSpPr>
-          <p:cNvPr id="2" name="Rectangle 1">
-            <a:extLst>
-              <a:ext uri="{FF2B5EF4-FFF2-40B4-BE49-F238E27FC236}">
-                <a16:creationId xmlns:a16="http://schemas.microsoft.com/office/drawing/2014/main" id="{DAC221A5-E89B-7CDB-57E7-88919BA17B8A}"/>
-              </a:ext>
-            </a:extLst>
-          </p:cNvPr>
-          <p:cNvSpPr/>
-          <p:nvPr/>
-        </p:nvSpPr>
-        <p:spPr>
-          <a:xfrm>
-            <a:off x="0" y="0"/>
-            <a:ext cx="12191695" cy="6858000"/>
-          </a:xfrm>
-          <a:prstGeom prst="rect">
-            <a:avLst/>
-          </a:prstGeom>
-          <a:solidFill>
-            <a:srgbClr val="1B2430"/>
-          </a:solidFill>
-          <a:ln>
-            <a:noFill/>
-          </a:ln>
-          <a:effectLst/>
-        </p:spPr>
-        <p:style>
-          <a:lnRef idx="1">
-            <a:schemeClr val="accent1"/>
-          </a:lnRef>
-          <a:fillRef idx="3">
-            <a:schemeClr val="accent1"/>
-          </a:fillRef>
-          <a:effectRef idx="2">
-            <a:schemeClr val="accent1"/>
-          </a:effectRef>
-          <a:fontRef idx="minor">
-            <a:schemeClr val="lt1"/>
-          </a:fontRef>
-        </p:style>
-        <p:txBody>
-          <a:bodyPr rtlCol="0" anchor="ctr"/>
-          <a:lstStyle/>
-          <a:p>
-            <a:pPr algn="ctr"/>
-            <a:endParaRPr/>
-          </a:p>
-        </p:txBody>
-      </p:sp>
-      <p:sp>
-        <p:nvSpPr>
-          <p:cNvPr id="3" name="TextBox 2">
-            <a:extLst>
-              <a:ext uri="{FF2B5EF4-FFF2-40B4-BE49-F238E27FC236}">
-                <a16:creationId xmlns:a16="http://schemas.microsoft.com/office/drawing/2014/main" id="{4BD1BD80-4047-F136-5392-68E72ABF82F1}"/>
-              </a:ext>
-            </a:extLst>
-          </p:cNvPr>
-          <p:cNvSpPr txBox="1"/>
-          <p:nvPr/>
-        </p:nvSpPr>
-        <p:spPr>
-          <a:xfrm>
-            <a:off x="4791075" y="3423225"/>
-            <a:ext cx="2466975" cy="584775"/>
-          </a:xfrm>
-          <a:prstGeom prst="rect">
-            <a:avLst/>
-          </a:prstGeom>
-          <a:noFill/>
-        </p:spPr>
-        <p:txBody>
-          <a:bodyPr wrap="square" lIns="0" tIns="0" rIns="0" bIns="0" anchor="t">
-            <a:spAutoFit/>
-          </a:bodyPr>
-          <a:lstStyle/>
-          <a:p>
-            <a:pPr algn="ctr">
-              <a:lnSpc>
-                <a:spcPct val="100000"/>
-              </a:lnSpc>
-            </a:pPr>
-            <a:r>
-              <a:rPr sz="3800" b="1" i="0" dirty="0">
-                <a:solidFill>
-                  <a:srgbClr val="FFFFFF"/>
-                </a:solidFill>
-                <a:latin typeface="Cambria"/>
-              </a:rPr>
-              <a:t>The </a:t>
-            </a:r>
-            <a:r>
-              <a:rPr lang="en-US" sz="3800" b="1" i="0" dirty="0">
-                <a:solidFill>
-                  <a:srgbClr val="FFFFFF"/>
-                </a:solidFill>
-                <a:latin typeface="Cambria"/>
-              </a:rPr>
-              <a:t>End</a:t>
-            </a:r>
-            <a:endParaRPr sz="3800" b="1" i="0" dirty="0">
-              <a:solidFill>
-                <a:srgbClr val="FFFFFF"/>
-              </a:solidFill>
-              <a:latin typeface="Cambria"/>
-            </a:endParaRPr>
-          </a:p>
-        </p:txBody>
-      </p:sp>
-    </p:spTree>
-    <p:extLst>
-      <p:ext uri="{BB962C8B-B14F-4D97-AF65-F5344CB8AC3E}">
-        <p14:creationId xmlns:p14="http://schemas.microsoft.com/office/powerpoint/2010/main" val="4225617154"/>
-      </p:ext>
-    </p:extLst>
   </p:cSld>
   <p:clrMapOvr>
     <a:masterClrMapping/>

</xml_diff>